<commit_message>
Apresentação: figuras e números da série 2010–2025
- scripts/figuras_apresentacao.R gera as figuras a partir só dos agregados
  suprimidos (data/export); substitui plots_exploratorios_pe.R,
  mapa_biossimilares.R e doses_adalimumabe.R, que liam microdados da v1
- Figuras trocadas dentro do .pptx editado à mão, com as mesmas proporções
  (layout, recortes e molduras preservados): pirâmide, mapa, PE × Brasil
  (agora pacientes em tratamento por 100 mil, já que o canal clínico de PE é
  quase vazio até 2024), fluxo de atendimento, dermatologistas × detecção
  (r = 0,62) e biossimilares
- Números do slide 4 (168.141 registros, 974 internações, 103 óbitos), legenda
  do slide 10 e notas dos slides 9, 10 e 13 atualizados; typo do slide 11
- Roteiro .md atualizado; gerar_apresentacao.R marcado como obsoleto

Co-Authored-By: Claude Opus 5.5 <noreply@anthropic.com>
</commit_message>
<xml_diff>
--- a/apresentacao_HS_15min.pptx
+++ b/apresentacao_HS_15min.pptx
@@ -2197,267 +2197,7 @@
           <a:p>
             <a:r>
               <a:rPr dirty="0" err="1"/>
-              <a:t>Não</a:t>
-            </a:r>
-            <a:r>
-              <a:rPr dirty="0"/>
-              <a:t> </a:t>
-            </a:r>
-            <a:r>
-              <a:rPr dirty="0" err="1"/>
-              <a:t>é</a:t>
-            </a:r>
-            <a:r>
-              <a:rPr dirty="0"/>
-              <a:t> </a:t>
-            </a:r>
-            <a:r>
-              <a:rPr dirty="0" err="1"/>
-              <a:t>que</a:t>
-            </a:r>
-            <a:r>
-              <a:rPr dirty="0"/>
-              <a:t> a HS </a:t>
-            </a:r>
-            <a:r>
-              <a:rPr dirty="0" err="1"/>
-              <a:t>não</a:t>
-            </a:r>
-            <a:r>
-              <a:rPr dirty="0"/>
-              <a:t> </a:t>
-            </a:r>
-            <a:r>
-              <a:rPr dirty="0" err="1"/>
-              <a:t>exista</a:t>
-            </a:r>
-            <a:r>
-              <a:rPr dirty="0"/>
-              <a:t> no Norte e no Nordeste. </a:t>
-            </a:r>
-            <a:r>
-              <a:rPr dirty="0" err="1"/>
-              <a:t>É</a:t>
-            </a:r>
-            <a:r>
-              <a:rPr dirty="0"/>
-              <a:t> </a:t>
-            </a:r>
-            <a:r>
-              <a:rPr dirty="0" err="1"/>
-              <a:t>que</a:t>
-            </a:r>
-            <a:r>
-              <a:rPr dirty="0"/>
-              <a:t>, </a:t>
-            </a:r>
-            <a:r>
-              <a:rPr dirty="0" err="1"/>
-              <a:t>em</a:t>
-            </a:r>
-            <a:r>
-              <a:rPr dirty="0"/>
-              <a:t> </a:t>
-            </a:r>
-            <a:r>
-              <a:rPr dirty="0" err="1"/>
-              <a:t>muitos</a:t>
-            </a:r>
-            <a:r>
-              <a:rPr dirty="0"/>
-              <a:t> </a:t>
-            </a:r>
-            <a:r>
-              <a:rPr dirty="0" err="1"/>
-              <a:t>lugares</a:t>
-            </a:r>
-            <a:r>
-              <a:rPr dirty="0"/>
-              <a:t>, </a:t>
-            </a:r>
-            <a:r>
-              <a:rPr dirty="0" err="1"/>
-              <a:t>não</a:t>
-            </a:r>
-            <a:r>
-              <a:rPr dirty="0"/>
-              <a:t> </a:t>
-            </a:r>
-            <a:r>
-              <a:rPr dirty="0" err="1"/>
-              <a:t>há</a:t>
-            </a:r>
-            <a:r>
-              <a:rPr dirty="0"/>
-              <a:t> quem </a:t>
-            </a:r>
-            <a:r>
-              <a:rPr dirty="0" err="1"/>
-              <a:t>diagnostique</a:t>
-            </a:r>
-            <a:r>
-              <a:rPr dirty="0"/>
-              <a:t>. Onde </a:t>
-            </a:r>
-            <a:r>
-              <a:rPr dirty="0" err="1"/>
-              <a:t>há</a:t>
-            </a:r>
-            <a:r>
-              <a:rPr dirty="0"/>
-              <a:t> </a:t>
-            </a:r>
-            <a:r>
-              <a:rPr dirty="0" err="1"/>
-              <a:t>mais</a:t>
-            </a:r>
-            <a:r>
-              <a:rPr dirty="0"/>
-              <a:t> </a:t>
-            </a:r>
-            <a:r>
-              <a:rPr dirty="0" err="1"/>
-              <a:t>dermatologistas</a:t>
-            </a:r>
-            <a:r>
-              <a:rPr dirty="0"/>
-              <a:t>, </a:t>
-            </a:r>
-            <a:r>
-              <a:rPr dirty="0" err="1"/>
-              <a:t>encontra</a:t>
-            </a:r>
-            <a:r>
-              <a:rPr dirty="0"/>
-              <a:t>-se </a:t>
-            </a:r>
-            <a:r>
-              <a:rPr dirty="0" err="1"/>
-              <a:t>mais</a:t>
-            </a:r>
-            <a:r>
-              <a:rPr dirty="0"/>
-              <a:t> HS — a </a:t>
-            </a:r>
-            <a:r>
-              <a:rPr dirty="0" err="1"/>
-              <a:t>diferença</a:t>
-            </a:r>
-            <a:r>
-              <a:rPr dirty="0"/>
-              <a:t> de </a:t>
-            </a:r>
-            <a:r>
-              <a:rPr dirty="0" err="1"/>
-              <a:t>oferta</a:t>
-            </a:r>
-            <a:r>
-              <a:rPr dirty="0"/>
-              <a:t> </a:t>
-            </a:r>
-            <a:r>
-              <a:rPr dirty="0" err="1"/>
-              <a:t>chega</a:t>
-            </a:r>
-            <a:r>
-              <a:rPr dirty="0"/>
-              <a:t> a 6 </a:t>
-            </a:r>
-            <a:r>
-              <a:rPr dirty="0" err="1"/>
-              <a:t>vezes</a:t>
-            </a:r>
-            <a:r>
-              <a:rPr dirty="0"/>
-              <a:t> entre </a:t>
-            </a:r>
-            <a:r>
-              <a:rPr dirty="0" err="1"/>
-              <a:t>estados</a:t>
-            </a:r>
-            <a:r>
-              <a:rPr dirty="0"/>
-              <a:t>. Uma </a:t>
-            </a:r>
-            <a:r>
-              <a:rPr dirty="0" err="1"/>
-              <a:t>doença</a:t>
-            </a:r>
-            <a:r>
-              <a:rPr dirty="0"/>
-              <a:t> </a:t>
-            </a:r>
-            <a:r>
-              <a:rPr dirty="0" err="1"/>
-              <a:t>que</a:t>
-            </a:r>
-            <a:r>
-              <a:rPr dirty="0"/>
-              <a:t> </a:t>
-            </a:r>
-            <a:r>
-              <a:rPr dirty="0" err="1"/>
-              <a:t>ninguém</a:t>
-            </a:r>
-            <a:r>
-              <a:rPr dirty="0"/>
-              <a:t> </a:t>
-            </a:r>
-            <a:r>
-              <a:rPr dirty="0" err="1"/>
-              <a:t>vê</a:t>
-            </a:r>
-            <a:r>
-              <a:rPr dirty="0"/>
-              <a:t> </a:t>
-            </a:r>
-            <a:r>
-              <a:rPr dirty="0" err="1"/>
-              <a:t>é</a:t>
-            </a:r>
-            <a:r>
-              <a:rPr dirty="0"/>
-              <a:t> </a:t>
-            </a:r>
-            <a:r>
-              <a:rPr dirty="0" err="1"/>
-              <a:t>uma</a:t>
-            </a:r>
-            <a:r>
-              <a:rPr dirty="0"/>
-              <a:t> </a:t>
-            </a:r>
-            <a:r>
-              <a:rPr dirty="0" err="1"/>
-              <a:t>doença</a:t>
-            </a:r>
-            <a:r>
-              <a:rPr dirty="0"/>
-              <a:t> </a:t>
-            </a:r>
-            <a:r>
-              <a:rPr dirty="0" err="1"/>
-              <a:t>que</a:t>
-            </a:r>
-            <a:r>
-              <a:rPr dirty="0"/>
-              <a:t> </a:t>
-            </a:r>
-            <a:r>
-              <a:rPr dirty="0" err="1"/>
-              <a:t>ninguém</a:t>
-            </a:r>
-            <a:r>
-              <a:rPr dirty="0"/>
-              <a:t> </a:t>
-            </a:r>
-            <a:r>
-              <a:rPr dirty="0" err="1"/>
-              <a:t>trata</a:t>
-            </a:r>
-            <a:r>
-              <a:rPr dirty="0"/>
-              <a:t>.</a:t>
+              <a:t>Não é que a HS não exista em boa parte do Norte e do Nordeste. É que, em muitos lugares, não há quem diagnostique. Onde há mais dermatologistas, encontra-se mais HS — e a oferta de dermatologistas varia quase 6 vezes entre os estados (2025). Uma doença que ninguém vê é uma doença que ninguém trata.</a:t>
             </a:r>
           </a:p>
         </p:txBody>
@@ -2504,227 +2244,7 @@
           <a:p>
             <a:r>
               <a:rPr dirty="0" err="1"/>
-              <a:t>É</a:t>
-            </a:r>
-            <a:r>
-              <a:rPr dirty="0"/>
-              <a:t> </a:t>
-            </a:r>
-            <a:r>
-              <a:rPr dirty="0" err="1"/>
-              <a:t>uma</a:t>
-            </a:r>
-            <a:r>
-              <a:rPr dirty="0"/>
-              <a:t> boa </a:t>
-            </a:r>
-            <a:r>
-              <a:rPr dirty="0" err="1"/>
-              <a:t>notícia</a:t>
-            </a:r>
-            <a:r>
-              <a:rPr dirty="0"/>
-              <a:t>: </a:t>
-            </a:r>
-            <a:r>
-              <a:rPr dirty="0" err="1"/>
-              <a:t>mais</a:t>
-            </a:r>
-            <a:r>
-              <a:rPr dirty="0"/>
-              <a:t> </a:t>
-            </a:r>
-            <a:r>
-              <a:rPr dirty="0" err="1"/>
-              <a:t>pessoas</a:t>
-            </a:r>
-            <a:r>
-              <a:rPr dirty="0"/>
-              <a:t> </a:t>
-            </a:r>
-            <a:r>
-              <a:rPr dirty="0" err="1"/>
-              <a:t>estão</a:t>
-            </a:r>
-            <a:r>
-              <a:rPr dirty="0"/>
-              <a:t> </a:t>
-            </a:r>
-            <a:r>
-              <a:rPr dirty="0" err="1"/>
-              <a:t>sendo</a:t>
-            </a:r>
-            <a:r>
-              <a:rPr dirty="0"/>
-              <a:t> vistas. Mas a </a:t>
-            </a:r>
-            <a:r>
-              <a:rPr dirty="0" err="1"/>
-              <a:t>pergunta</a:t>
-            </a:r>
-            <a:r>
-              <a:rPr dirty="0"/>
-              <a:t> </a:t>
-            </a:r>
-            <a:r>
-              <a:rPr dirty="0" err="1"/>
-              <a:t>é</a:t>
-            </a:r>
-            <a:r>
-              <a:rPr dirty="0"/>
-              <a:t>: </a:t>
-            </a:r>
-            <a:r>
-              <a:rPr dirty="0" err="1"/>
-              <a:t>todas</a:t>
-            </a:r>
-            <a:r>
-              <a:rPr dirty="0"/>
-              <a:t> as </a:t>
-            </a:r>
-            <a:r>
-              <a:rPr dirty="0" err="1"/>
-              <a:t>regiões</a:t>
-            </a:r>
-            <a:r>
-              <a:rPr dirty="0"/>
-              <a:t> </a:t>
-            </a:r>
-            <a:r>
-              <a:rPr dirty="0" err="1"/>
-              <a:t>cresceram</a:t>
-            </a:r>
-            <a:r>
-              <a:rPr dirty="0"/>
-              <a:t> </a:t>
-            </a:r>
-            <a:r>
-              <a:rPr dirty="0" err="1"/>
-              <a:t>igual</a:t>
-            </a:r>
-            <a:r>
-              <a:rPr dirty="0"/>
-              <a:t>? </a:t>
-            </a:r>
-            <a:r>
-              <a:rPr dirty="0" err="1"/>
-              <a:t>Já</a:t>
-            </a:r>
-            <a:r>
-              <a:rPr dirty="0"/>
-              <a:t> </a:t>
-            </a:r>
-            <a:r>
-              <a:rPr dirty="0" err="1"/>
-              <a:t>já</a:t>
-            </a:r>
-            <a:r>
-              <a:rPr dirty="0"/>
-              <a:t> a </a:t>
-            </a:r>
-            <a:r>
-              <a:rPr dirty="0" err="1"/>
-              <a:t>gente</a:t>
-            </a:r>
-            <a:r>
-              <a:rPr dirty="0"/>
-              <a:t> </a:t>
-            </a:r>
-            <a:r>
-              <a:rPr dirty="0" err="1"/>
-              <a:t>descobre</a:t>
-            </a:r>
-            <a:r>
-              <a:rPr dirty="0"/>
-              <a:t> </a:t>
-            </a:r>
-            <a:r>
-              <a:rPr dirty="0" err="1"/>
-              <a:t>que</a:t>
-            </a:r>
-            <a:r>
-              <a:rPr dirty="0"/>
-              <a:t> </a:t>
-            </a:r>
-            <a:r>
-              <a:rPr dirty="0" err="1"/>
-              <a:t>não</a:t>
-            </a:r>
-            <a:r>
-              <a:rPr dirty="0"/>
-              <a:t>. (</a:t>
-            </a:r>
-            <a:r>
-              <a:rPr dirty="0" err="1"/>
-              <a:t>Dica</a:t>
-            </a:r>
-            <a:r>
-              <a:rPr dirty="0"/>
-              <a:t>: </a:t>
-            </a:r>
-            <a:r>
-              <a:rPr dirty="0" err="1"/>
-              <a:t>na</a:t>
-            </a:r>
-            <a:r>
-              <a:rPr dirty="0"/>
-              <a:t> </a:t>
-            </a:r>
-            <a:r>
-              <a:rPr dirty="0" err="1"/>
-              <a:t>arte</a:t>
-            </a:r>
-            <a:r>
-              <a:rPr dirty="0"/>
-              <a:t> final, </a:t>
-            </a:r>
-            <a:r>
-              <a:rPr dirty="0" err="1"/>
-              <a:t>simplifique</a:t>
-            </a:r>
-            <a:r>
-              <a:rPr dirty="0"/>
-              <a:t> para </a:t>
-            </a:r>
-            <a:r>
-              <a:rPr dirty="0" err="1"/>
-              <a:t>mostrar</a:t>
-            </a:r>
-            <a:r>
-              <a:rPr dirty="0"/>
-              <a:t> </a:t>
-            </a:r>
-            <a:r>
-              <a:rPr dirty="0" err="1"/>
-              <a:t>só</a:t>
-            </a:r>
-            <a:r>
-              <a:rPr dirty="0"/>
-              <a:t> a </a:t>
-            </a:r>
-            <a:r>
-              <a:rPr dirty="0" err="1"/>
-              <a:t>linha</a:t>
-            </a:r>
-            <a:r>
-              <a:rPr dirty="0"/>
-              <a:t> do </a:t>
-            </a:r>
-            <a:r>
-              <a:rPr dirty="0" err="1"/>
-              <a:t>atendimento</a:t>
-            </a:r>
-            <a:r>
-              <a:rPr dirty="0"/>
-              <a:t> ambulatorial </a:t>
-            </a:r>
-            <a:r>
-              <a:rPr dirty="0" err="1"/>
-              <a:t>subindo</a:t>
-            </a:r>
-            <a:r>
-              <a:rPr dirty="0"/>
-              <a:t>.)</a:t>
+              <a:t>É uma boa notícia: desde que o SUS passou a oferecer o adalimumabe para HS, em novembro de 2019, o número de pessoas em tratamento cresce todo ano. Em Pernambuco, foi de poucas pessoas em 2020 para cerca de 150 pacientes por mês em 2025. Mas a pergunta é: todas as regiões cresceram igual? Já já a gente descobre que não.</a:t>
             </a:r>
           </a:p>
         </p:txBody>
@@ -2771,235 +2291,7 @@
           <a:p>
             <a:r>
               <a:rPr dirty="0"/>
-              <a:t>A </a:t>
-            </a:r>
-            <a:r>
-              <a:rPr dirty="0" err="1"/>
-              <a:t>maior</a:t>
-            </a:r>
-            <a:r>
-              <a:rPr dirty="0"/>
-              <a:t> </a:t>
-            </a:r>
-            <a:r>
-              <a:rPr dirty="0" err="1"/>
-              <a:t>parte</a:t>
-            </a:r>
-            <a:r>
-              <a:rPr dirty="0"/>
-              <a:t> dos </a:t>
-            </a:r>
-            <a:r>
-              <a:rPr dirty="0" err="1"/>
-              <a:t>atendimentos</a:t>
-            </a:r>
-            <a:r>
-              <a:rPr dirty="0"/>
-              <a:t> </a:t>
-            </a:r>
-            <a:r>
-              <a:rPr dirty="0" err="1"/>
-              <a:t>hoje</a:t>
-            </a:r>
-            <a:r>
-              <a:rPr lang="it-IT" dirty="0"/>
-              <a:t> (cerca de 90%)</a:t>
-            </a:r>
-            <a:r>
-              <a:rPr dirty="0"/>
-              <a:t> </a:t>
-            </a:r>
-            <a:r>
-              <a:rPr dirty="0" err="1"/>
-              <a:t>é</a:t>
-            </a:r>
-            <a:r>
-              <a:rPr dirty="0"/>
-              <a:t> a </a:t>
-            </a:r>
-            <a:r>
-              <a:rPr dirty="0" err="1"/>
-              <a:t>entrega</a:t>
-            </a:r>
-            <a:r>
-              <a:rPr dirty="0"/>
-              <a:t> do </a:t>
-            </a:r>
-            <a:r>
-              <a:rPr dirty="0" err="1"/>
-              <a:t>medicamento</a:t>
-            </a:r>
-            <a:r>
-              <a:rPr dirty="0"/>
-              <a:t> </a:t>
-            </a:r>
-            <a:r>
-              <a:rPr dirty="0" err="1"/>
-              <a:t>biológico</a:t>
-            </a:r>
-            <a:r>
-              <a:rPr dirty="0"/>
-              <a:t> (</a:t>
-            </a:r>
-            <a:r>
-              <a:rPr dirty="0" err="1"/>
-              <a:t>adalimumabe</a:t>
-            </a:r>
-            <a:r>
-              <a:rPr dirty="0"/>
-              <a:t>). </a:t>
-            </a:r>
-            <a:r>
-              <a:rPr dirty="0" err="1"/>
-              <a:t>Biossimilar</a:t>
-            </a:r>
-            <a:r>
-              <a:rPr dirty="0"/>
-              <a:t> </a:t>
-            </a:r>
-            <a:r>
-              <a:rPr dirty="0" err="1"/>
-              <a:t>não</a:t>
-            </a:r>
-            <a:r>
-              <a:rPr dirty="0"/>
-              <a:t> </a:t>
-            </a:r>
-            <a:r>
-              <a:rPr dirty="0" err="1"/>
-              <a:t>é</a:t>
-            </a:r>
-            <a:r>
-              <a:rPr dirty="0"/>
-              <a:t> </a:t>
-            </a:r>
-            <a:r>
-              <a:rPr dirty="0" err="1"/>
-              <a:t>remédio</a:t>
-            </a:r>
-            <a:r>
-              <a:rPr dirty="0"/>
-              <a:t> de </a:t>
-            </a:r>
-            <a:r>
-              <a:rPr dirty="0" err="1"/>
-              <a:t>segunda</a:t>
-            </a:r>
-            <a:r>
-              <a:rPr dirty="0"/>
-              <a:t> </a:t>
-            </a:r>
-            <a:r>
-              <a:rPr dirty="0" err="1"/>
-              <a:t>linha</a:t>
-            </a:r>
-            <a:r>
-              <a:rPr dirty="0"/>
-              <a:t>: </a:t>
-            </a:r>
-            <a:r>
-              <a:rPr dirty="0" err="1"/>
-              <a:t>é</a:t>
-            </a:r>
-            <a:r>
-              <a:rPr dirty="0"/>
-              <a:t> </a:t>
-            </a:r>
-            <a:r>
-              <a:rPr dirty="0" err="1"/>
-              <a:t>equivalente</a:t>
-            </a:r>
-            <a:r>
-              <a:rPr dirty="0"/>
-              <a:t>, com </a:t>
-            </a:r>
-            <a:r>
-              <a:rPr dirty="0" err="1"/>
-              <a:t>mesma</a:t>
-            </a:r>
-            <a:r>
-              <a:rPr dirty="0"/>
-              <a:t> </a:t>
-            </a:r>
-            <a:r>
-              <a:rPr dirty="0" err="1"/>
-              <a:t>eficácia</a:t>
-            </a:r>
-            <a:r>
-              <a:rPr dirty="0"/>
-              <a:t> e </a:t>
-            </a:r>
-            <a:r>
-              <a:rPr dirty="0" err="1"/>
-              <a:t>segurança</a:t>
-            </a:r>
-            <a:r>
-              <a:rPr dirty="0"/>
-              <a:t>, </a:t>
-            </a:r>
-            <a:r>
-              <a:rPr dirty="0" err="1"/>
-              <a:t>custando</a:t>
-            </a:r>
-            <a:r>
-              <a:rPr dirty="0"/>
-              <a:t> </a:t>
-            </a:r>
-            <a:r>
-              <a:rPr dirty="0" err="1"/>
-              <a:t>menos</a:t>
-            </a:r>
-            <a:r>
-              <a:rPr dirty="0"/>
-              <a:t>. Cada real </a:t>
-            </a:r>
-            <a:r>
-              <a:rPr dirty="0" err="1"/>
-              <a:t>economizado</a:t>
-            </a:r>
-            <a:r>
-              <a:rPr dirty="0"/>
-              <a:t> </a:t>
-            </a:r>
-            <a:r>
-              <a:rPr dirty="0" err="1"/>
-              <a:t>pode</a:t>
-            </a:r>
-            <a:r>
-              <a:rPr dirty="0"/>
-              <a:t> </a:t>
-            </a:r>
-            <a:r>
-              <a:rPr dirty="0" err="1"/>
-              <a:t>virar</a:t>
-            </a:r>
-            <a:r>
-              <a:rPr dirty="0"/>
-              <a:t> </a:t>
-            </a:r>
-            <a:r>
-              <a:rPr dirty="0" err="1"/>
-              <a:t>acesso</a:t>
-            </a:r>
-            <a:r>
-              <a:rPr dirty="0"/>
-              <a:t> para </a:t>
-            </a:r>
-            <a:r>
-              <a:rPr dirty="0" err="1"/>
-              <a:t>outra</a:t>
-            </a:r>
-            <a:r>
-              <a:rPr dirty="0"/>
-              <a:t> </a:t>
-            </a:r>
-            <a:r>
-              <a:rPr dirty="0" err="1"/>
-              <a:t>pessoa</a:t>
-            </a:r>
-            <a:r>
-              <a:rPr dirty="0"/>
-              <a:t>.</a:t>
+              <a:t>A maior parte dos registros ambulatoriais de HS hoje (mais de 8 em cada 10) é a entrega do medicamento biológico (adalimumabe). Biossimilar não é remédio de segunda linha: é equivalente, com mesma eficácia e segurança, custando menos. Cada real economizado pode virar acesso para outra pessoa.</a:t>
             </a:r>
           </a:p>
         </p:txBody>
@@ -5465,7 +4757,7 @@
                 <a:latin typeface="Calibri"/>
                 <a:cs typeface="Calibri"/>
               </a:rPr>
-              <a:t>Mais pessoas estão sendo vistas pelo SUS — um sinal de que a doença vem sendo mais reconhecida.</a:t>
+              <a:t>Desde 2019, com o adalimumabe no SUS, mais pessoas com HS recebem tratamento.</a:t>
             </a:r>
           </a:p>
         </p:txBody>
@@ -5935,7 +5227,7 @@
                 <a:latin typeface="Calibri"/>
                 <a:cs typeface="Calibri"/>
               </a:rPr>
-              <a:t>Percentual de pessoas atendidas no no próprio município vs. fora dele.</a:t>
+              <a:t>Percentual de pessoas atendidas no próprio município vs. fora dele.</a:t>
             </a:r>
           </a:p>
         </p:txBody>
@@ -9302,7 +8594,7 @@
                 <a:latin typeface="Calibri"/>
                 <a:cs typeface="Calibri"/>
               </a:rPr>
-              <a:t>Cada atendimento no SUS gera um registro — sem nome, protegido. Olhamos milhões deles, de 2020 a 2025, em três sistemas:</a:t>
+              <a:t>Cada atendimento no SUS gera um registro — sem nome, protegido. Olhamos milhões deles, de 2010 a 2025, em três sistemas:</a:t>
             </a:r>
           </a:p>
         </p:txBody>
@@ -9400,7 +8692,7 @@
                 <a:latin typeface="Calibri"/>
                 <a:cs typeface="Calibri"/>
               </a:rPr>
-              <a:t>158.850</a:t>
+              <a:t>168.141</a:t>
             </a:r>
           </a:p>
         </p:txBody>
@@ -9588,7 +8880,7 @@
                 <a:latin typeface="Calibri"/>
                 <a:cs typeface="Calibri"/>
               </a:rPr>
-              <a:t>631</a:t>
+              <a:t>974</a:t>
             </a:r>
           </a:p>
         </p:txBody>
@@ -9776,7 +9068,7 @@
                 <a:latin typeface="Calibri"/>
                 <a:cs typeface="Calibri"/>
               </a:rPr>
-              <a:t>96</a:t>
+              <a:t>103</a:t>
             </a:r>
           </a:p>
         </p:txBody>

</xml_diff>